<commit_message>
Update Module 7 and 8 slide decks
Refresh the 7.1 Power BI environment deck and the 8.1, 8.2 and 8.3
Practical AI decks. The 8.1 deck was re-exported under a name missing
its hyphen; restore the hyphenated filename so it stays consistent with
8.2 and 8.3 and records as an edit rather than a delete plus add.

Co-Authored-By: Claude Opus 5 (1M context) <noreply@anthropic.com>
</commit_message>
<xml_diff>
--- a/MODULE-07-BUSINESS-INTELLIGENCE-WITH-POWER-BI/week-08-Business Intelligence with Power BI/01-the-power-bi-environment-and-data-loading/slides/7.1_The Power BI Environment and Data Loading.pptx
+++ b/MODULE-07-BUSINESS-INTELLIGENCE-WITH-POWER-BI/week-08-Business Intelligence with Power BI/01-the-power-bi-environment-and-data-loading/slides/7.1_The Power BI Environment and Data Loading.pptx
@@ -31223,7 +31223,7 @@
         </p:nvGrpSpPr>
         <p:grpSpPr>
           <a:xfrm rot="0">
-            <a:off x="1143000" y="3191199"/>
+            <a:off x="1143000" y="3979545"/>
             <a:ext cx="457200" cy="485775"/>
             <a:chOff x="0" y="0"/>
             <a:chExt cx="609600" cy="647700"/>
@@ -31284,7 +31284,7 @@
         </p:nvGrpSpPr>
         <p:grpSpPr>
           <a:xfrm rot="0">
-            <a:off x="1143000" y="4162749"/>
+            <a:off x="1143000" y="4951095"/>
             <a:ext cx="457200" cy="485775"/>
             <a:chOff x="0" y="0"/>
             <a:chExt cx="609600" cy="647700"/>
@@ -31467,7 +31467,7 @@
         </p:nvGrpSpPr>
         <p:grpSpPr>
           <a:xfrm rot="0">
-            <a:off x="1143000" y="5220024"/>
+            <a:off x="1143000" y="6008370"/>
             <a:ext cx="457200" cy="485775"/>
             <a:chOff x="0" y="0"/>
             <a:chExt cx="609600" cy="647700"/>
@@ -31685,7 +31685,7 @@
                 <a:cs typeface="Poppins"/>
                 <a:sym typeface="Poppins"/>
               </a:rPr>
-              <a:t>Lo</a:t>
+              <a:t>What is </a:t>
             </a:r>
             <a:r>
               <a:rPr lang="en-US" sz="2700">
@@ -31697,7 +31697,7 @@
                 <a:cs typeface="Poppins"/>
                 <a:sym typeface="Poppins"/>
               </a:rPr>
-              <a:t>ad, clean and model data correctly in Power BI</a:t>
+              <a:t>Power BI </a:t>
             </a:r>
           </a:p>
         </p:txBody>
@@ -31710,7 +31710,7 @@
         </p:nvSpPr>
         <p:spPr>
           <a:xfrm rot="0">
-            <a:off x="1857375" y="3051181"/>
+            <a:off x="1857375" y="3839528"/>
             <a:ext cx="7286625" cy="584835"/>
           </a:xfrm>
           <a:prstGeom prst="rect">
@@ -31751,7 +31751,7 @@
         </p:nvSpPr>
         <p:spPr>
           <a:xfrm rot="0">
-            <a:off x="1857375" y="4022731"/>
+            <a:off x="1857375" y="4811078"/>
             <a:ext cx="8261167" cy="584835"/>
           </a:xfrm>
           <a:prstGeom prst="rect">
@@ -31804,7 +31804,7 @@
         </p:nvSpPr>
         <p:spPr>
           <a:xfrm rot="0">
-            <a:off x="1857375" y="5039049"/>
+            <a:off x="1857375" y="5827395"/>
             <a:ext cx="8060714" cy="1194435"/>
           </a:xfrm>
           <a:prstGeom prst="rect">
@@ -31845,6 +31845,120 @@
                 <a:sym typeface="Poppins"/>
               </a:rPr>
               <a:t>efine a capstone question and sign off a dataset.</a:t>
+            </a:r>
+          </a:p>
+        </p:txBody>
+      </p:sp>
+      <p:grpSp>
+        <p:nvGrpSpPr>
+          <p:cNvPr name="Group 25" id="25"/>
+          <p:cNvGrpSpPr/>
+          <p:nvPr/>
+        </p:nvGrpSpPr>
+        <p:grpSpPr>
+          <a:xfrm rot="0">
+            <a:off x="1143000" y="3141345"/>
+            <a:ext cx="457200" cy="485775"/>
+            <a:chOff x="0" y="0"/>
+            <a:chExt cx="609600" cy="647700"/>
+          </a:xfrm>
+        </p:grpSpPr>
+        <p:sp>
+          <p:nvSpPr>
+            <p:cNvPr name="Freeform 26" id="26" descr="image.png"/>
+            <p:cNvSpPr/>
+            <p:nvPr/>
+          </p:nvSpPr>
+          <p:spPr>
+            <a:xfrm flipH="false" flipV="false" rot="0">
+              <a:off x="0" y="0"/>
+              <a:ext cx="609600" cy="647700"/>
+            </a:xfrm>
+            <a:custGeom>
+              <a:avLst/>
+              <a:gdLst/>
+              <a:ahLst/>
+              <a:cxnLst/>
+              <a:rect r="r" b="b" t="t" l="l"/>
+              <a:pathLst>
+                <a:path h="647700" w="609600">
+                  <a:moveTo>
+                    <a:pt x="0" y="0"/>
+                  </a:moveTo>
+                  <a:lnTo>
+                    <a:pt x="609600" y="0"/>
+                  </a:lnTo>
+                  <a:lnTo>
+                    <a:pt x="609600" y="647700"/>
+                  </a:lnTo>
+                  <a:lnTo>
+                    <a:pt x="0" y="647700"/>
+                  </a:lnTo>
+                  <a:lnTo>
+                    <a:pt x="0" y="0"/>
+                  </a:lnTo>
+                  <a:close/>
+                </a:path>
+              </a:pathLst>
+            </a:custGeom>
+            <a:blipFill>
+              <a:blip r:embed="rId4"/>
+              <a:stretch>
+                <a:fillRect l="0" t="0" r="0" b="0"/>
+              </a:stretch>
+            </a:blipFill>
+          </p:spPr>
+        </p:sp>
+      </p:grpSp>
+      <p:sp>
+        <p:nvSpPr>
+          <p:cNvPr name="TextBox 27" id="27"/>
+          <p:cNvSpPr txBox="true"/>
+          <p:nvPr/>
+        </p:nvSpPr>
+        <p:spPr>
+          <a:xfrm rot="0">
+            <a:off x="1857375" y="3001328"/>
+            <a:ext cx="8546611" cy="584835"/>
+          </a:xfrm>
+          <a:prstGeom prst="rect">
+            <a:avLst/>
+          </a:prstGeom>
+        </p:spPr>
+        <p:txBody>
+          <a:bodyPr anchor="t" rtlCol="false" tIns="0" lIns="0" bIns="0" rIns="0">
+            <a:spAutoFit/>
+          </a:bodyPr>
+          <a:lstStyle/>
+          <a:p>
+            <a:pPr algn="l">
+              <a:lnSpc>
+                <a:spcPts val="4860"/>
+              </a:lnSpc>
+            </a:pPr>
+            <a:r>
+              <a:rPr lang="en-US" sz="2700">
+                <a:solidFill>
+                  <a:srgbClr val="1E293B"/>
+                </a:solidFill>
+                <a:latin typeface="Poppins"/>
+                <a:ea typeface="Poppins"/>
+                <a:cs typeface="Poppins"/>
+                <a:sym typeface="Poppins"/>
+              </a:rPr>
+              <a:t>Lo</a:t>
+            </a:r>
+            <a:r>
+              <a:rPr lang="en-US" sz="2700">
+                <a:solidFill>
+                  <a:srgbClr val="1E293B"/>
+                </a:solidFill>
+                <a:latin typeface="Poppins"/>
+                <a:ea typeface="Poppins"/>
+                <a:cs typeface="Poppins"/>
+                <a:sym typeface="Poppins"/>
+              </a:rPr>
+              <a:t>ad, clean and model data correctly in Power BI</a:t>
             </a:r>
           </a:p>
         </p:txBody>

</xml_diff>